<commit_message>
v8: fix all accents (tildes) in index and timeline
</commit_message>
<xml_diff>
--- a/TFM_Presentacion_Denisa_Antoneac_v8.pptx
+++ b/TFM_Presentacion_Denisa_Antoneac_v8.pptx
@@ -275,7 +275,7 @@
           <a:p>
             <a:fld id="{CA247015-7F4A-4C41-B618-B3138CAFA7DE}" type="datetimeFigureOut">
               <a:rPr lang="es-ES" smtClean="0"/>
-              <a:t>21/06/2026</a:t>
+              <a:t>20/06/2026</a:t>
             </a:fld>
             <a:endParaRPr lang="es-ES"/>
           </a:p>
@@ -473,7 +473,7 @@
           <a:p>
             <a:fld id="{CA247015-7F4A-4C41-B618-B3138CAFA7DE}" type="datetimeFigureOut">
               <a:rPr lang="es-ES" smtClean="0"/>
-              <a:t>21/06/2026</a:t>
+              <a:t>20/06/2026</a:t>
             </a:fld>
             <a:endParaRPr lang="es-ES"/>
           </a:p>
@@ -681,7 +681,7 @@
           <a:p>
             <a:fld id="{CA247015-7F4A-4C41-B618-B3138CAFA7DE}" type="datetimeFigureOut">
               <a:rPr lang="es-ES" smtClean="0"/>
-              <a:t>21/06/2026</a:t>
+              <a:t>20/06/2026</a:t>
             </a:fld>
             <a:endParaRPr lang="es-ES"/>
           </a:p>
@@ -879,7 +879,7 @@
           <a:p>
             <a:fld id="{CA247015-7F4A-4C41-B618-B3138CAFA7DE}" type="datetimeFigureOut">
               <a:rPr lang="es-ES" smtClean="0"/>
-              <a:t>21/06/2026</a:t>
+              <a:t>20/06/2026</a:t>
             </a:fld>
             <a:endParaRPr lang="es-ES"/>
           </a:p>
@@ -1154,7 +1154,7 @@
           <a:p>
             <a:fld id="{CA247015-7F4A-4C41-B618-B3138CAFA7DE}" type="datetimeFigureOut">
               <a:rPr lang="es-ES" smtClean="0"/>
-              <a:t>21/06/2026</a:t>
+              <a:t>20/06/2026</a:t>
             </a:fld>
             <a:endParaRPr lang="es-ES"/>
           </a:p>
@@ -1419,7 +1419,7 @@
           <a:p>
             <a:fld id="{CA247015-7F4A-4C41-B618-B3138CAFA7DE}" type="datetimeFigureOut">
               <a:rPr lang="es-ES" smtClean="0"/>
-              <a:t>21/06/2026</a:t>
+              <a:t>20/06/2026</a:t>
             </a:fld>
             <a:endParaRPr lang="es-ES"/>
           </a:p>
@@ -1831,7 +1831,7 @@
           <a:p>
             <a:fld id="{CA247015-7F4A-4C41-B618-B3138CAFA7DE}" type="datetimeFigureOut">
               <a:rPr lang="es-ES" smtClean="0"/>
-              <a:t>21/06/2026</a:t>
+              <a:t>20/06/2026</a:t>
             </a:fld>
             <a:endParaRPr lang="es-ES"/>
           </a:p>
@@ -1972,7 +1972,7 @@
           <a:p>
             <a:fld id="{CA247015-7F4A-4C41-B618-B3138CAFA7DE}" type="datetimeFigureOut">
               <a:rPr lang="es-ES" smtClean="0"/>
-              <a:t>21/06/2026</a:t>
+              <a:t>20/06/2026</a:t>
             </a:fld>
             <a:endParaRPr lang="es-ES"/>
           </a:p>
@@ -2085,7 +2085,7 @@
           <a:p>
             <a:fld id="{CA247015-7F4A-4C41-B618-B3138CAFA7DE}" type="datetimeFigureOut">
               <a:rPr lang="es-ES" smtClean="0"/>
-              <a:t>21/06/2026</a:t>
+              <a:t>20/06/2026</a:t>
             </a:fld>
             <a:endParaRPr lang="es-ES"/>
           </a:p>
@@ -2396,7 +2396,7 @@
           <a:p>
             <a:fld id="{CA247015-7F4A-4C41-B618-B3138CAFA7DE}" type="datetimeFigureOut">
               <a:rPr lang="es-ES" smtClean="0"/>
-              <a:t>21/06/2026</a:t>
+              <a:t>20/06/2026</a:t>
             </a:fld>
             <a:endParaRPr lang="es-ES"/>
           </a:p>
@@ -2684,7 +2684,7 @@
           <a:p>
             <a:fld id="{CA247015-7F4A-4C41-B618-B3138CAFA7DE}" type="datetimeFigureOut">
               <a:rPr lang="es-ES" smtClean="0"/>
-              <a:t>21/06/2026</a:t>
+              <a:t>20/06/2026</a:t>
             </a:fld>
             <a:endParaRPr lang="es-ES"/>
           </a:p>
@@ -2925,7 +2925,7 @@
           <a:p>
             <a:fld id="{CA247015-7F4A-4C41-B618-B3138CAFA7DE}" type="datetimeFigureOut">
               <a:rPr lang="es-ES" smtClean="0"/>
-              <a:t>21/06/2026</a:t>
+              <a:t>20/06/2026</a:t>
             </a:fld>
             <a:endParaRPr lang="es-ES"/>
           </a:p>
@@ -3372,7 +3372,7 @@
           <a:p>
             <a:pPr algn="l"/>
             <a:r>
-              <a:rPr sz="1600" b="1" spc="160" dirty="0">
+              <a:rPr sz="1200" b="1" spc="160">
                 <a:solidFill>
                   <a:srgbClr val="9C99A6"/>
                 </a:solidFill>
@@ -3391,8 +3391,8 @@
         </p:nvSpPr>
         <p:spPr>
           <a:xfrm>
-            <a:off x="656590" y="1522432"/>
-            <a:ext cx="8110219" cy="3174683"/>
+            <a:off x="574040" y="1699260"/>
+            <a:ext cx="7680960" cy="2011680"/>
           </a:xfrm>
           <a:prstGeom prst="rect">
             <a:avLst/>
@@ -3403,13 +3403,13 @@
           <a:bodyPr wrap="square" lIns="0" tIns="0" rIns="0" bIns="0" anchor="t"/>
           <a:lstStyle/>
           <a:p>
-            <a:pPr>
+            <a:pPr algn="l">
               <a:lnSpc>
                 <a:spcPct val="104000"/>
               </a:lnSpc>
             </a:pPr>
             <a:r>
-              <a:rPr sz="4000" b="0" dirty="0" err="1">
+              <a:rPr sz="4300" b="0" dirty="0" err="1">
                 <a:solidFill>
                   <a:srgbClr val="2E2A3A"/>
                 </a:solidFill>
@@ -3418,7 +3418,7 @@
               <a:t>Cómo</a:t>
             </a:r>
             <a:r>
-              <a:rPr sz="4000" b="0" dirty="0">
+              <a:rPr sz="4300" b="0" dirty="0">
                 <a:solidFill>
                   <a:srgbClr val="2E2A3A"/>
                 </a:solidFill>
@@ -3427,7 +3427,7 @@
               <a:t> </a:t>
             </a:r>
             <a:r>
-              <a:rPr sz="4000" b="0" dirty="0" err="1">
+              <a:rPr sz="4300" b="0" dirty="0" err="1">
                 <a:solidFill>
                   <a:srgbClr val="2E2A3A"/>
                 </a:solidFill>
@@ -3436,7 +3436,7 @@
               <a:t>afectan</a:t>
             </a:r>
             <a:r>
-              <a:rPr sz="4000" b="0" dirty="0">
+              <a:rPr sz="4300" b="0" dirty="0">
                 <a:solidFill>
                   <a:srgbClr val="2E2A3A"/>
                 </a:solidFill>
@@ -3445,7 +3445,7 @@
               <a:t> la </a:t>
             </a:r>
             <a:r>
-              <a:rPr sz="4000" b="0" dirty="0" err="1">
+              <a:rPr sz="4300" b="0" dirty="0" err="1">
                 <a:solidFill>
                   <a:srgbClr val="2E2A3A"/>
                 </a:solidFill>
@@ -3454,7 +3454,7 @@
               <a:t>autoestima</a:t>
             </a:r>
             <a:r>
-              <a:rPr sz="4000" b="0" dirty="0">
+              <a:rPr sz="4300" b="0" dirty="0">
                 <a:solidFill>
                   <a:srgbClr val="2E2A3A"/>
                 </a:solidFill>
@@ -3463,78 +3463,69 @@
               <a:t> </a:t>
             </a:r>
             <a:r>
-              <a:rPr lang="es-ES" sz="4000" b="0" dirty="0">
+              <a:rPr lang="es-ES" sz="4300" b="0" dirty="0">
                 <a:solidFill>
                   <a:srgbClr val="2E2A3A"/>
                 </a:solidFill>
                 <a:latin typeface="Georgia"/>
               </a:rPr>
+              <a:t>     </a:t>
+            </a:r>
+            <a:r>
+              <a:rPr lang="es-ES" sz="4300" dirty="0">
+                <a:solidFill>
+                  <a:srgbClr val="2E2A3A"/>
+                </a:solidFill>
+                <a:latin typeface="Georgia"/>
+              </a:rPr>
+              <a:t>y </a:t>
+            </a:r>
+            <a:r>
+              <a:rPr sz="4300" b="0" dirty="0" err="1">
+                <a:solidFill>
+                  <a:srgbClr val="2E2A3A"/>
+                </a:solidFill>
+                <a:latin typeface="Georgia"/>
+              </a:rPr>
+              <a:t>el</a:t>
+            </a:r>
+            <a:r>
+              <a:rPr sz="4300" b="0" dirty="0">
+                <a:solidFill>
+                  <a:srgbClr val="2E2A3A"/>
+                </a:solidFill>
+                <a:latin typeface="Georgia"/>
+              </a:rPr>
               <a:t> </a:t>
             </a:r>
             <a:r>
-              <a:rPr lang="es-ES" sz="4000" dirty="0">
+              <a:rPr sz="4300" b="0" dirty="0" err="1">
                 <a:solidFill>
                   <a:srgbClr val="2E2A3A"/>
                 </a:solidFill>
                 <a:latin typeface="Georgia"/>
               </a:rPr>
-              <a:t>y </a:t>
-            </a:r>
-            <a:r>
-              <a:rPr sz="4000" b="0" dirty="0" err="1">
+              <a:t>autoconcepto</a:t>
+            </a:r>
+            <a:r>
+              <a:rPr sz="4300" b="0" dirty="0">
                 <a:solidFill>
                   <a:srgbClr val="2E2A3A"/>
                 </a:solidFill>
                 <a:latin typeface="Georgia"/>
               </a:rPr>
-              <a:t>el</a:t>
-            </a:r>
-            <a:r>
-              <a:rPr sz="4000" b="0" dirty="0">
+              <a:t> al </a:t>
+            </a:r>
+            <a:r>
+              <a:rPr sz="4300" b="0" dirty="0" err="1">
                 <a:solidFill>
                   <a:srgbClr val="2E2A3A"/>
                 </a:solidFill>
                 <a:latin typeface="Georgia"/>
               </a:rPr>
-              <a:t> </a:t>
-            </a:r>
-            <a:r>
-              <a:rPr sz="4000" b="0" dirty="0" err="1">
-                <a:solidFill>
-                  <a:srgbClr val="2E2A3A"/>
-                </a:solidFill>
-                <a:latin typeface="Georgia"/>
-              </a:rPr>
-              <a:t>autoconcepto</a:t>
-            </a:r>
-            <a:r>
-              <a:rPr sz="4000" b="0" dirty="0">
-                <a:solidFill>
-                  <a:srgbClr val="2E2A3A"/>
-                </a:solidFill>
-                <a:latin typeface="Georgia"/>
-              </a:rPr>
-              <a:t> al </a:t>
-            </a:r>
-            <a:r>
-              <a:rPr sz="4000" b="0" dirty="0" err="1">
-                <a:solidFill>
-                  <a:srgbClr val="2E2A3A"/>
-                </a:solidFill>
-                <a:latin typeface="Georgia"/>
-              </a:rPr>
               <a:t>bienestar</a:t>
             </a:r>
-            <a:r>
-              <a:rPr lang="es-ES" sz="4000" b="0" dirty="0">
-                <a:solidFill>
-                  <a:srgbClr val="2E2A3A"/>
-                </a:solidFill>
-                <a:latin typeface="Georgia"/>
-              </a:rPr>
-              <a:t>: Una revisión paraguas en psicología clínica y de la salud (2016-2026)</a:t>
-            </a:r>
-            <a:endParaRPr sz="4000" b="0" dirty="0">
+            <a:endParaRPr sz="4300" b="0" dirty="0">
               <a:solidFill>
                 <a:srgbClr val="2E2A3A"/>
               </a:solidFill>
@@ -3545,13 +3536,185 @@
       </p:sp>
       <p:sp>
         <p:nvSpPr>
+          <p:cNvPr id="5" name="TextBox 4"/>
+          <p:cNvSpPr txBox="1"/>
+          <p:nvPr/>
+        </p:nvSpPr>
+        <p:spPr>
+          <a:xfrm>
+            <a:off x="965200" y="3382518"/>
+            <a:ext cx="7315200" cy="731520"/>
+          </a:xfrm>
+          <a:prstGeom prst="rect">
+            <a:avLst/>
+          </a:prstGeom>
+          <a:noFill/>
+        </p:spPr>
+        <p:txBody>
+          <a:bodyPr wrap="square" lIns="0" tIns="0" rIns="0" bIns="0" anchor="t"/>
+          <a:lstStyle/>
+          <a:p>
+            <a:pPr algn="l">
+              <a:lnSpc>
+                <a:spcPct val="112000"/>
+              </a:lnSpc>
+            </a:pPr>
+            <a:r>
+              <a:rPr sz="2400" b="0" dirty="0">
+                <a:solidFill>
+                  <a:srgbClr val="4C4954"/>
+                </a:solidFill>
+                <a:latin typeface="Segoe UI"/>
+              </a:rPr>
+              <a:t>Una </a:t>
+            </a:r>
+            <a:r>
+              <a:rPr sz="2400" b="0" dirty="0" err="1">
+                <a:solidFill>
+                  <a:srgbClr val="4C4954"/>
+                </a:solidFill>
+                <a:latin typeface="Segoe UI"/>
+              </a:rPr>
+              <a:t>revisión</a:t>
+            </a:r>
+            <a:r>
+              <a:rPr sz="2400" b="0" dirty="0">
+                <a:solidFill>
+                  <a:srgbClr val="4C4954"/>
+                </a:solidFill>
+                <a:latin typeface="Segoe UI"/>
+              </a:rPr>
+              <a:t> </a:t>
+            </a:r>
+            <a:r>
+              <a:rPr sz="2400" b="0" dirty="0" err="1">
+                <a:solidFill>
+                  <a:srgbClr val="4C4954"/>
+                </a:solidFill>
+                <a:latin typeface="Segoe UI"/>
+              </a:rPr>
+              <a:t>paraguas</a:t>
+            </a:r>
+            <a:r>
+              <a:rPr sz="2400" b="0" dirty="0">
+                <a:solidFill>
+                  <a:srgbClr val="4C4954"/>
+                </a:solidFill>
+                <a:latin typeface="Segoe UI"/>
+              </a:rPr>
+              <a:t> de meta-</a:t>
+            </a:r>
+            <a:r>
+              <a:rPr sz="2400" b="0" dirty="0" err="1">
+                <a:solidFill>
+                  <a:srgbClr val="4C4954"/>
+                </a:solidFill>
+                <a:latin typeface="Segoe UI"/>
+              </a:rPr>
+              <a:t>análisis</a:t>
+            </a:r>
+            <a:r>
+              <a:rPr sz="2400" b="0" dirty="0">
+                <a:solidFill>
+                  <a:srgbClr val="4C4954"/>
+                </a:solidFill>
+                <a:latin typeface="Segoe UI"/>
+              </a:rPr>
+              <a:t> </a:t>
+            </a:r>
+            <a:r>
+              <a:rPr sz="2400" b="0" dirty="0" err="1">
+                <a:solidFill>
+                  <a:srgbClr val="4C4954"/>
+                </a:solidFill>
+                <a:latin typeface="Segoe UI"/>
+              </a:rPr>
+              <a:t>en</a:t>
+            </a:r>
+            <a:r>
+              <a:rPr sz="2400" b="0" dirty="0">
+                <a:solidFill>
+                  <a:srgbClr val="4C4954"/>
+                </a:solidFill>
+                <a:latin typeface="Segoe UI"/>
+              </a:rPr>
+              <a:t> </a:t>
+            </a:r>
+            <a:r>
+              <a:rPr lang="es-ES" sz="2400" b="0" dirty="0">
+                <a:solidFill>
+                  <a:srgbClr val="4C4954"/>
+                </a:solidFill>
+                <a:latin typeface="Segoe UI"/>
+              </a:rPr>
+              <a:t>    </a:t>
+            </a:r>
+            <a:r>
+              <a:rPr sz="2400" b="0" dirty="0" err="1">
+                <a:solidFill>
+                  <a:srgbClr val="4C4954"/>
+                </a:solidFill>
+                <a:latin typeface="Segoe UI"/>
+              </a:rPr>
+              <a:t>psicología</a:t>
+            </a:r>
+            <a:r>
+              <a:rPr sz="2400" b="0" dirty="0">
+                <a:solidFill>
+                  <a:srgbClr val="4C4954"/>
+                </a:solidFill>
+                <a:latin typeface="Segoe UI"/>
+              </a:rPr>
+              <a:t> </a:t>
+            </a:r>
+            <a:r>
+              <a:rPr sz="2400" b="0" dirty="0" err="1">
+                <a:solidFill>
+                  <a:srgbClr val="4C4954"/>
+                </a:solidFill>
+                <a:latin typeface="Segoe UI"/>
+              </a:rPr>
+              <a:t>clínica</a:t>
+            </a:r>
+            <a:r>
+              <a:rPr sz="2400" b="0" dirty="0">
+                <a:solidFill>
+                  <a:srgbClr val="4C4954"/>
+                </a:solidFill>
+                <a:latin typeface="Segoe UI"/>
+              </a:rPr>
+              <a:t> y de la </a:t>
+            </a:r>
+            <a:r>
+              <a:rPr sz="2400" b="0" dirty="0" err="1">
+                <a:solidFill>
+                  <a:srgbClr val="4C4954"/>
+                </a:solidFill>
+                <a:latin typeface="Segoe UI"/>
+              </a:rPr>
+              <a:t>salud</a:t>
+            </a:r>
+            <a:r>
+              <a:rPr sz="2400" b="0" dirty="0">
+                <a:solidFill>
+                  <a:srgbClr val="4C4954"/>
+                </a:solidFill>
+                <a:latin typeface="Segoe UI"/>
+              </a:rPr>
+              <a:t> (2016–2026)</a:t>
+            </a:r>
+          </a:p>
+        </p:txBody>
+      </p:sp>
+      <p:sp>
+        <p:nvSpPr>
           <p:cNvPr id="6" name="Rounded Rectangle 5"/>
           <p:cNvSpPr/>
           <p:nvPr/>
         </p:nvSpPr>
         <p:spPr>
           <a:xfrm>
-            <a:off x="656862" y="4484438"/>
+            <a:off x="762000" y="4494276"/>
             <a:ext cx="1188720" cy="77724"/>
           </a:xfrm>
           <a:prstGeom prst="roundRect">
@@ -3906,8 +4069,8 @@
         </p:nvSpPr>
         <p:spPr>
           <a:xfrm>
-            <a:off x="8069931" y="2729683"/>
-            <a:ext cx="2494044" cy="2304186"/>
+            <a:off x="8851265" y="2921000"/>
+            <a:ext cx="3302000" cy="3302000"/>
           </a:xfrm>
           <a:prstGeom prst="ellipse">
             <a:avLst/>
@@ -3963,8 +4126,8 @@
         </p:nvSpPr>
         <p:spPr>
           <a:xfrm>
-            <a:off x="9620366" y="3011368"/>
-            <a:ext cx="2494044" cy="2277839"/>
+            <a:off x="6903992" y="2804377"/>
+            <a:ext cx="3347902" cy="3291623"/>
           </a:xfrm>
           <a:prstGeom prst="ellipse">
             <a:avLst/>
@@ -4020,8 +4183,8 @@
         </p:nvSpPr>
         <p:spPr>
           <a:xfrm>
-            <a:off x="8766809" y="1174496"/>
-            <a:ext cx="2986495" cy="3002062"/>
+            <a:off x="7874000" y="762000"/>
+            <a:ext cx="3810000" cy="3810000"/>
           </a:xfrm>
           <a:prstGeom prst="ellipse">
             <a:avLst/>
@@ -4408,7 +4571,7 @@
         </p:nvSpPr>
         <p:spPr>
           <a:xfrm>
-            <a:off x="2820924" y="2697479"/>
+            <a:off x="3008376" y="2697479"/>
             <a:ext cx="2011680" cy="320040"/>
           </a:xfrm>
           <a:prstGeom prst="rect">
@@ -4422,14 +4585,14 @@
           <a:p>
             <a:pPr algn="l"/>
             <a:r>
-              <a:rPr lang="es-ES" sz="1350" b="0" dirty="0">
-                <a:latin typeface="Segoe UI"/>
-              </a:rPr>
-              <a:t>0</a:t>
-            </a:r>
-            <a:endParaRPr sz="1350" b="0" dirty="0">
-              <a:latin typeface="Segoe UI"/>
-            </a:endParaRPr>
+              <a:rPr sz="1350" b="0">
+                <a:solidFill>
+                  <a:srgbClr val="9C99A6"/>
+                </a:solidFill>
+                <a:latin typeface="Segoe UI"/>
+              </a:rPr>
+              <a:t>0   (ninguno)</a:t>
+            </a:r>
           </a:p>
         </p:txBody>
       </p:sp>
@@ -7794,58 +7957,13 @@
           <a:p>
             <a:pPr algn="l"/>
             <a:r>
-              <a:rPr sz="1050" b="0" dirty="0" err="1">
+              <a:rPr sz="1050" b="0">
                 <a:solidFill>
                   <a:srgbClr val="9C99A6"/>
                 </a:solidFill>
                 <a:latin typeface="Segoe UI"/>
               </a:rPr>
-              <a:t>Autoestima</a:t>
-            </a:r>
-            <a:r>
-              <a:rPr sz="1050" b="0" dirty="0">
-                <a:solidFill>
-                  <a:srgbClr val="9C99A6"/>
-                </a:solidFill>
-                <a:latin typeface="Segoe UI"/>
-              </a:rPr>
-              <a:t>, </a:t>
-            </a:r>
-            <a:r>
-              <a:rPr sz="1050" b="0" dirty="0" err="1">
-                <a:solidFill>
-                  <a:srgbClr val="9C99A6"/>
-                </a:solidFill>
-                <a:latin typeface="Segoe UI"/>
-              </a:rPr>
-              <a:t>autoconcepto</a:t>
-            </a:r>
-            <a:r>
-              <a:rPr sz="1050" b="0" dirty="0">
-                <a:solidFill>
-                  <a:srgbClr val="9C99A6"/>
-                </a:solidFill>
-                <a:latin typeface="Segoe UI"/>
-              </a:rPr>
-              <a:t> y </a:t>
-            </a:r>
-            <a:r>
-              <a:rPr sz="1050" b="0" dirty="0" err="1">
-                <a:solidFill>
-                  <a:srgbClr val="9C99A6"/>
-                </a:solidFill>
-                <a:latin typeface="Segoe UI"/>
-              </a:rPr>
-              <a:t>bienestar</a:t>
-            </a:r>
-            <a:r>
-              <a:rPr sz="1050" b="0" dirty="0">
-                <a:solidFill>
-                  <a:srgbClr val="9C99A6"/>
-                </a:solidFill>
-                <a:latin typeface="Segoe UI"/>
-              </a:rPr>
-              <a:t>   ·   D. Antoneac</a:t>
+              <a:t>Autoestima, autoconcepto y bienestar   ·   D. Antoneac</a:t>
             </a:r>
           </a:p>
         </p:txBody>
@@ -9203,38 +9321,14 @@
           <a:p>
             <a:pPr algn="l"/>
             <a:r>
-              <a:rPr lang="es-ES" sz="1550" b="1" dirty="0">
+              <a:rPr sz="1550" b="1">
                 <a:solidFill>
                   <a:srgbClr val="2E2A3A"/>
                 </a:solidFill>
                 <a:latin typeface="Segoe UI Semibold"/>
               </a:rPr>
-              <a:t>Limitaciones d</a:t>
-            </a:r>
-            <a:r>
-              <a:rPr sz="1550" b="1" dirty="0">
-                <a:solidFill>
-                  <a:srgbClr val="2E2A3A"/>
-                </a:solidFill>
-                <a:latin typeface="Segoe UI Semibold"/>
-              </a:rPr>
-              <a:t>e la </a:t>
-            </a:r>
-            <a:r>
-              <a:rPr sz="1550" b="1" dirty="0" err="1">
-                <a:solidFill>
-                  <a:srgbClr val="2E2A3A"/>
-                </a:solidFill>
-                <a:latin typeface="Segoe UI Semibold"/>
-              </a:rPr>
-              <a:t>evidencia</a:t>
-            </a:r>
-            <a:endParaRPr sz="1550" b="1" dirty="0">
-              <a:solidFill>
-                <a:srgbClr val="2E2A3A"/>
-              </a:solidFill>
-              <a:latin typeface="Segoe UI Semibold"/>
-            </a:endParaRPr>
+              <a:t>De la evidencia</a:t>
+            </a:r>
           </a:p>
         </p:txBody>
       </p:sp>
@@ -9598,56 +9692,14 @@
           <a:p>
             <a:pPr algn="l"/>
             <a:r>
-              <a:rPr lang="es-ES" sz="1550" b="1" dirty="0" err="1">
+              <a:rPr sz="1550" b="1">
                 <a:solidFill>
                   <a:srgbClr val="2E2A3A"/>
                 </a:solidFill>
                 <a:latin typeface="Segoe UI Semibold"/>
               </a:rPr>
-              <a:t>Limitacciones</a:t>
-            </a:r>
-            <a:r>
-              <a:rPr lang="es-ES" sz="1550" b="1" dirty="0">
-                <a:solidFill>
-                  <a:srgbClr val="2E2A3A"/>
-                </a:solidFill>
-                <a:latin typeface="Segoe UI Semibold"/>
-              </a:rPr>
-              <a:t> d</a:t>
-            </a:r>
-            <a:r>
-              <a:rPr sz="1550" b="1" dirty="0" err="1">
-                <a:solidFill>
-                  <a:srgbClr val="2E2A3A"/>
-                </a:solidFill>
-                <a:latin typeface="Segoe UI Semibold"/>
-              </a:rPr>
-              <a:t>el</a:t>
-            </a:r>
-            <a:r>
-              <a:rPr sz="1550" b="1" dirty="0">
-                <a:solidFill>
-                  <a:srgbClr val="2E2A3A"/>
-                </a:solidFill>
-                <a:latin typeface="Segoe UI Semibold"/>
-              </a:rPr>
-              <a:t> </a:t>
-            </a:r>
-            <a:r>
-              <a:rPr sz="1550" b="1" dirty="0" err="1">
-                <a:solidFill>
-                  <a:srgbClr val="2E2A3A"/>
-                </a:solidFill>
-                <a:latin typeface="Segoe UI Semibold"/>
-              </a:rPr>
-              <a:t>proceso</a:t>
-            </a:r>
-            <a:endParaRPr sz="1550" b="1" dirty="0">
-              <a:solidFill>
-                <a:srgbClr val="2E2A3A"/>
-              </a:solidFill>
-              <a:latin typeface="Segoe UI Semibold"/>
-            </a:endParaRPr>
+              <a:t>Del proceso</a:t>
+            </a:r>
           </a:p>
         </p:txBody>
       </p:sp>
@@ -11720,7 +11772,7 @@
                   <a:srgbClr val="9079C8"/>
                 </a:solidFill>
               </a:rPr>
-              <a:t>INDICE</a:t>
+              <a:t>ÍNDICE</a:t>
             </a:r>
           </a:p>
         </p:txBody>
@@ -11754,7 +11806,7 @@
                   <a:srgbClr val="2E2A3A"/>
                 </a:solidFill>
               </a:rPr>
-              <a:t>Estructura de la presentacion</a:t>
+              <a:t>Estructura de la presentación</a:t>
             </a:r>
           </a:p>
         </p:txBody>
@@ -11865,7 +11917,7 @@
                   <a:srgbClr val="2E2A3A"/>
                 </a:solidFill>
               </a:rPr>
-              <a:t>Marco Teorico</a:t>
+              <a:t>Marco Teórico</a:t>
             </a:r>
           </a:p>
         </p:txBody>
@@ -12010,7 +12062,7 @@
                   <a:srgbClr val="2E2A3A"/>
                 </a:solidFill>
               </a:rPr>
-              <a:t>Justificacion</a:t>
+              <a:t>Justificación</a:t>
             </a:r>
           </a:p>
         </p:txBody>
@@ -12044,7 +12096,7 @@
                   <a:srgbClr val="4C4954"/>
                 </a:solidFill>
               </a:rPr>
-              <a:t>Por que este trabajo y que anade</a:t>
+              <a:t>Por qué este trabajo y qué añade</a:t>
             </a:r>
           </a:p>
         </p:txBody>
@@ -12189,7 +12241,7 @@
                   <a:srgbClr val="4C4954"/>
                 </a:solidFill>
               </a:rPr>
-              <a:t>General y cuatro especificos</a:t>
+              <a:t>General y cuatro específicos</a:t>
             </a:r>
           </a:p>
         </p:txBody>
@@ -12300,7 +12352,7 @@
                   <a:srgbClr val="2E2A3A"/>
                 </a:solidFill>
               </a:rPr>
-              <a:t>Metodo</a:t>
+              <a:t>Método</a:t>
             </a:r>
           </a:p>
         </p:txBody>
@@ -12334,7 +12386,7 @@
                   <a:srgbClr val="4C4954"/>
                 </a:solidFill>
               </a:rPr>
-              <a:t>Diseno PECO, busqueda y seleccion</a:t>
+              <a:t>Diseño PECO, búsqueda y selección</a:t>
             </a:r>
           </a:p>
         </p:txBody>
@@ -12479,7 +12531,7 @@
                   <a:srgbClr val="4C4954"/>
                 </a:solidFill>
               </a:rPr>
-              <a:t>Corpus, calidad AMSTAR-2 y sintesis por bloques</a:t>
+              <a:t>Corpus, calidad AMSTAR-2 y síntesis por bloques</a:t>
             </a:r>
           </a:p>
         </p:txBody>
@@ -12590,7 +12642,7 @@
                   <a:srgbClr val="2E2A3A"/>
                 </a:solidFill>
               </a:rPr>
-              <a:t>Discusion y Conclusiones</a:t>
+              <a:t>Discusión y Conclusiones</a:t>
             </a:r>
           </a:p>
         </p:txBody>
@@ -12624,7 +12676,7 @@
                   <a:srgbClr val="4C4954"/>
                 </a:solidFill>
               </a:rPr>
-              <a:t>Implicaciones clinicas, limitaciones y lineas futuras</a:t>
+              <a:t>Implicaciones clínicas, limitaciones y líneas futuras</a:t>
             </a:r>
           </a:p>
         </p:txBody>
@@ -12789,8 +12841,8 @@
         </p:nvSpPr>
         <p:spPr>
           <a:xfrm>
-            <a:off x="766000" y="528066"/>
-            <a:ext cx="374902" cy="176022"/>
+            <a:off x="749808" y="566928"/>
+            <a:ext cx="310896" cy="91440"/>
           </a:xfrm>
           <a:prstGeom prst="roundRect">
             <a:avLst>
@@ -12850,29 +12902,14 @@
           <a:p>
             <a:pPr algn="l"/>
             <a:r>
-              <a:rPr sz="2000" b="1" spc="140" dirty="0">
+              <a:rPr sz="1150" b="1" spc="140">
                 <a:solidFill>
                   <a:srgbClr val="9079C8"/>
                 </a:solidFill>
                 <a:latin typeface="Segoe UI Semibold"/>
               </a:rPr>
-              <a:t>MARCO TEÓRICO · </a:t>
-            </a:r>
-            <a:r>
-              <a:rPr lang="es-ES" sz="2000" b="1" spc="140" dirty="0">
-                <a:solidFill>
-                  <a:srgbClr val="9079C8"/>
-                </a:solidFill>
-                <a:latin typeface="Segoe UI Semibold"/>
-              </a:rPr>
-              <a:t>SELF</a:t>
-            </a:r>
-            <a:endParaRPr sz="2000" b="1" spc="140" dirty="0">
-              <a:solidFill>
-                <a:srgbClr val="9079C8"/>
-              </a:solidFill>
-              <a:latin typeface="Segoe UI Semibold"/>
-            </a:endParaRPr>
+              <a:t>MARCO TEÓRICO · UN SIGLO</a:t>
+            </a:r>
           </a:p>
         </p:txBody>
       </p:sp>
@@ -12995,7 +13032,7 @@
           <a:lstStyle/>
           <a:p>
             <a:pPr algn="ctr"/>
-            <a:endParaRPr sz="2000"/>
+            <a:endParaRPr sz="2400"/>
           </a:p>
         </p:txBody>
       </p:sp>
@@ -13008,7 +13045,7 @@
         <p:spPr>
           <a:xfrm>
             <a:off x="896888" y="5212080"/>
-            <a:ext cx="10725912" cy="1161288"/>
+            <a:ext cx="10725912" cy="777240"/>
           </a:xfrm>
           <a:prstGeom prst="roundRect">
             <a:avLst>
@@ -13054,8 +13091,8 @@
         </p:nvSpPr>
         <p:spPr>
           <a:xfrm>
-            <a:off x="676268" y="5237000"/>
-            <a:ext cx="147080" cy="1104198"/>
+            <a:off x="749808" y="5212080"/>
+            <a:ext cx="82296" cy="777240"/>
           </a:xfrm>
           <a:prstGeom prst="rect">
             <a:avLst/>
@@ -13113,287 +13150,23 @@
           <a:p>
             <a:pPr algn="l"/>
             <a:r>
-              <a:rPr sz="1400" b="1" dirty="0" err="1">
+              <a:rPr sz="1000" b="1">
                 <a:solidFill>
                   <a:srgbClr val="2E2A3A"/>
                 </a:solidFill>
               </a:rPr>
-              <a:t>Falacias</a:t>
-            </a:r>
-            <a:r>
-              <a:rPr lang="es-ES" sz="1400" b="1" dirty="0">
-                <a:solidFill>
-                  <a:srgbClr val="2E2A3A"/>
-                </a:solidFill>
-              </a:rPr>
-              <a:t>:</a:t>
+              <a:t>Falacias jingle / jangle</a:t>
             </a:r>
           </a:p>
           <a:p>
             <a:pPr algn="l"/>
-            <a:endParaRPr lang="es-ES" sz="700" b="1" dirty="0">
-              <a:solidFill>
-                <a:srgbClr val="2E2A3A"/>
-              </a:solidFill>
-            </a:endParaRPr>
-          </a:p>
-          <a:p>
-            <a:pPr algn="l"/>
-            <a:r>
-              <a:rPr sz="1400" b="1" dirty="0">
+            <a:r>
+              <a:rPr sz="900" b="0">
                 <a:solidFill>
                   <a:srgbClr val="4C4954"/>
                 </a:solidFill>
               </a:rPr>
-              <a:t>Jingle</a:t>
-            </a:r>
-            <a:r>
-              <a:rPr sz="1400" b="0" dirty="0">
-                <a:solidFill>
-                  <a:srgbClr val="4C4954"/>
-                </a:solidFill>
-              </a:rPr>
-              <a:t>: </a:t>
-            </a:r>
-            <a:r>
-              <a:rPr sz="1400" b="0" dirty="0" err="1">
-                <a:solidFill>
-                  <a:srgbClr val="4C4954"/>
-                </a:solidFill>
-              </a:rPr>
-              <a:t>mismo</a:t>
-            </a:r>
-            <a:r>
-              <a:rPr sz="1400" b="0" dirty="0">
-                <a:solidFill>
-                  <a:srgbClr val="4C4954"/>
-                </a:solidFill>
-              </a:rPr>
-              <a:t> </a:t>
-            </a:r>
-            <a:r>
-              <a:rPr sz="1400" b="0" dirty="0" err="1">
-                <a:solidFill>
-                  <a:srgbClr val="4C4954"/>
-                </a:solidFill>
-              </a:rPr>
-              <a:t>nombre</a:t>
-            </a:r>
-            <a:r>
-              <a:rPr sz="1400" b="0" dirty="0">
-                <a:solidFill>
-                  <a:srgbClr val="4C4954"/>
-                </a:solidFill>
-              </a:rPr>
-              <a:t>, </a:t>
-            </a:r>
-            <a:r>
-              <a:rPr sz="1400" b="0" dirty="0" err="1">
-                <a:solidFill>
-                  <a:srgbClr val="4C4954"/>
-                </a:solidFill>
-              </a:rPr>
-              <a:t>constructos</a:t>
-            </a:r>
-            <a:r>
-              <a:rPr sz="1400" b="0" dirty="0">
-                <a:solidFill>
-                  <a:srgbClr val="4C4954"/>
-                </a:solidFill>
-              </a:rPr>
-              <a:t> </a:t>
-            </a:r>
-            <a:r>
-              <a:rPr sz="1400" b="0" dirty="0" err="1">
-                <a:solidFill>
-                  <a:srgbClr val="4C4954"/>
-                </a:solidFill>
-              </a:rPr>
-              <a:t>distintos</a:t>
-            </a:r>
-            <a:r>
-              <a:rPr sz="1400" b="0" dirty="0">
-                <a:solidFill>
-                  <a:srgbClr val="4C4954"/>
-                </a:solidFill>
-              </a:rPr>
-              <a:t>.  </a:t>
-            </a:r>
-            <a:endParaRPr lang="es-ES" sz="1400" b="0" dirty="0">
-              <a:solidFill>
-                <a:srgbClr val="4C4954"/>
-              </a:solidFill>
-            </a:endParaRPr>
-          </a:p>
-          <a:p>
-            <a:pPr algn="l"/>
-            <a:endParaRPr lang="es-ES" sz="200" b="0" dirty="0">
-              <a:solidFill>
-                <a:srgbClr val="4C4954"/>
-              </a:solidFill>
-            </a:endParaRPr>
-          </a:p>
-          <a:p>
-            <a:pPr algn="l"/>
-            <a:r>
-              <a:rPr sz="1400" b="1" dirty="0">
-                <a:solidFill>
-                  <a:srgbClr val="4C4954"/>
-                </a:solidFill>
-              </a:rPr>
-              <a:t>Jangle</a:t>
-            </a:r>
-            <a:r>
-              <a:rPr sz="1400" b="0" dirty="0">
-                <a:solidFill>
-                  <a:srgbClr val="4C4954"/>
-                </a:solidFill>
-              </a:rPr>
-              <a:t>: </a:t>
-            </a:r>
-            <a:r>
-              <a:rPr sz="1400" b="0" dirty="0" err="1">
-                <a:solidFill>
-                  <a:srgbClr val="4C4954"/>
-                </a:solidFill>
-              </a:rPr>
-              <a:t>mismo</a:t>
-            </a:r>
-            <a:r>
-              <a:rPr sz="1400" b="0" dirty="0">
-                <a:solidFill>
-                  <a:srgbClr val="4C4954"/>
-                </a:solidFill>
-              </a:rPr>
-              <a:t> </a:t>
-            </a:r>
-            <a:r>
-              <a:rPr sz="1400" b="0" dirty="0" err="1">
-                <a:solidFill>
-                  <a:srgbClr val="4C4954"/>
-                </a:solidFill>
-              </a:rPr>
-              <a:t>constructo</a:t>
-            </a:r>
-            <a:r>
-              <a:rPr sz="1400" b="0" dirty="0">
-                <a:solidFill>
-                  <a:srgbClr val="4C4954"/>
-                </a:solidFill>
-              </a:rPr>
-              <a:t>, </a:t>
-            </a:r>
-            <a:r>
-              <a:rPr sz="1400" b="0" dirty="0" err="1">
-                <a:solidFill>
-                  <a:srgbClr val="4C4954"/>
-                </a:solidFill>
-              </a:rPr>
-              <a:t>nombres</a:t>
-            </a:r>
-            <a:r>
-              <a:rPr sz="1400" b="0" dirty="0">
-                <a:solidFill>
-                  <a:srgbClr val="4C4954"/>
-                </a:solidFill>
-              </a:rPr>
-              <a:t> </a:t>
-            </a:r>
-            <a:r>
-              <a:rPr sz="1400" b="0" dirty="0" err="1">
-                <a:solidFill>
-                  <a:srgbClr val="4C4954"/>
-                </a:solidFill>
-              </a:rPr>
-              <a:t>distintos</a:t>
-            </a:r>
-            <a:r>
-              <a:rPr sz="1400" b="0" dirty="0">
-                <a:solidFill>
-                  <a:srgbClr val="4C4954"/>
-                </a:solidFill>
-              </a:rPr>
-              <a:t>.  El </a:t>
-            </a:r>
-            <a:r>
-              <a:rPr sz="1400" b="0" dirty="0" err="1">
-                <a:solidFill>
-                  <a:srgbClr val="4C4954"/>
-                </a:solidFill>
-              </a:rPr>
-              <a:t>instrumento</a:t>
-            </a:r>
-            <a:r>
-              <a:rPr sz="1400" b="0" dirty="0">
-                <a:solidFill>
-                  <a:srgbClr val="4C4954"/>
-                </a:solidFill>
-              </a:rPr>
-              <a:t> </a:t>
-            </a:r>
-            <a:r>
-              <a:rPr sz="1400" b="0" dirty="0" err="1">
-                <a:solidFill>
-                  <a:srgbClr val="4C4954"/>
-                </a:solidFill>
-              </a:rPr>
-              <a:t>elegido</a:t>
-            </a:r>
-            <a:r>
-              <a:rPr sz="1400" b="0" dirty="0">
-                <a:solidFill>
-                  <a:srgbClr val="4C4954"/>
-                </a:solidFill>
-              </a:rPr>
-              <a:t> define que </a:t>
-            </a:r>
-            <a:r>
-              <a:rPr sz="1400" b="0" dirty="0" err="1">
-                <a:solidFill>
-                  <a:srgbClr val="4C4954"/>
-                </a:solidFill>
-              </a:rPr>
-              <a:t>constructo</a:t>
-            </a:r>
-            <a:r>
-              <a:rPr sz="1400" b="0" dirty="0">
-                <a:solidFill>
-                  <a:srgbClr val="4C4954"/>
-                </a:solidFill>
-              </a:rPr>
-              <a:t> se </a:t>
-            </a:r>
-            <a:r>
-              <a:rPr sz="1400" b="0" dirty="0" err="1">
-                <a:solidFill>
-                  <a:srgbClr val="4C4954"/>
-                </a:solidFill>
-              </a:rPr>
-              <a:t>mide</a:t>
-            </a:r>
-            <a:r>
-              <a:rPr sz="1400" b="0" dirty="0">
-                <a:solidFill>
-                  <a:srgbClr val="4C4954"/>
-                </a:solidFill>
-              </a:rPr>
-              <a:t> </a:t>
-            </a:r>
-            <a:r>
-              <a:rPr sz="1400" b="0" dirty="0" err="1">
-                <a:solidFill>
-                  <a:srgbClr val="4C4954"/>
-                </a:solidFill>
-              </a:rPr>
-              <a:t>realmente</a:t>
-            </a:r>
-            <a:r>
-              <a:rPr sz="1400" b="0" dirty="0">
-                <a:solidFill>
-                  <a:srgbClr val="4C4954"/>
-                </a:solidFill>
-              </a:rPr>
-              <a:t>.</a:t>
+              <a:t>Jingle: mismo nombre, constructos distintos.  Jangle: mismo constructo, nombres distintos.  El instrumento elegido define qué constructo se mide realmente.</a:t>
             </a:r>
           </a:p>
         </p:txBody>
@@ -13524,7 +13297,7 @@
         <p:spPr>
           <a:xfrm>
             <a:off x="766000" y="2148840"/>
-            <a:ext cx="1660000" cy="400110"/>
+            <a:ext cx="1660000" cy="457200"/>
           </a:xfrm>
           <a:prstGeom prst="rect">
             <a:avLst/>
@@ -13539,7 +13312,7 @@
           <a:p>
             <a:pPr algn="ctr"/>
             <a:r>
-              <a:rPr sz="2000" b="1">
+              <a:rPr sz="2600" b="1">
                 <a:solidFill>
                   <a:srgbClr val="9079C8"/>
                 </a:solidFill>
@@ -13558,7 +13331,7 @@
         <p:spPr>
           <a:xfrm>
             <a:off x="766000" y="2670048"/>
-            <a:ext cx="2000060" cy="400110"/>
+            <a:ext cx="1660000" cy="320040"/>
           </a:xfrm>
           <a:prstGeom prst="rect">
             <a:avLst/>
@@ -13573,7 +13346,7 @@
           <a:p>
             <a:pPr algn="ctr"/>
             <a:r>
-              <a:rPr sz="2000" b="1" dirty="0">
+              <a:rPr sz="950" b="1">
                 <a:solidFill>
                   <a:srgbClr val="2E2A3A"/>
                 </a:solidFill>
@@ -13623,7 +13396,6 @@
           <a:lstStyle/>
           <a:p>
             <a:pPr algn="ctr"/>
-            <a:endParaRPr sz="2000"/>
           </a:p>
         </p:txBody>
       </p:sp>
@@ -13636,7 +13408,7 @@
         <p:spPr>
           <a:xfrm>
             <a:off x="766000" y="3794760"/>
-            <a:ext cx="1660000" cy="830997"/>
+            <a:ext cx="1660000" cy="1050000"/>
           </a:xfrm>
           <a:prstGeom prst="rect">
             <a:avLst/>
@@ -13651,7 +13423,7 @@
           <a:p>
             <a:pPr algn="ctr"/>
             <a:r>
-              <a:rPr sz="1600" b="0">
+              <a:rPr sz="850" b="0">
                 <a:solidFill>
                   <a:srgbClr val="4C4954"/>
                 </a:solidFill>
@@ -13662,7 +13434,7 @@
           <a:p>
             <a:pPr algn="ctr"/>
             <a:r>
-              <a:rPr sz="1600" b="0">
+              <a:rPr sz="850" b="0">
                 <a:solidFill>
                   <a:srgbClr val="4C4954"/>
                 </a:solidFill>
@@ -13673,7 +13445,7 @@
           <a:p>
             <a:pPr algn="ctr"/>
             <a:r>
-              <a:rPr sz="1600" b="0">
+              <a:rPr sz="850" b="0">
                 <a:solidFill>
                   <a:srgbClr val="4C4954"/>
                 </a:solidFill>
@@ -13692,7 +13464,7 @@
         <p:spPr>
           <a:xfrm>
             <a:off x="2566000" y="2148840"/>
-            <a:ext cx="1660000" cy="400110"/>
+            <a:ext cx="1660000" cy="457200"/>
           </a:xfrm>
           <a:prstGeom prst="rect">
             <a:avLst/>
@@ -13707,7 +13479,7 @@
           <a:p>
             <a:pPr algn="ctr"/>
             <a:r>
-              <a:rPr sz="2000" b="1">
+              <a:rPr sz="2600" b="1">
                 <a:solidFill>
                   <a:srgbClr val="9079C8"/>
                 </a:solidFill>
@@ -13726,7 +13498,7 @@
         <p:spPr>
           <a:xfrm>
             <a:off x="2566000" y="2670048"/>
-            <a:ext cx="1660000" cy="400110"/>
+            <a:ext cx="1660000" cy="320040"/>
           </a:xfrm>
           <a:prstGeom prst="rect">
             <a:avLst/>
@@ -13741,7 +13513,7 @@
           <a:p>
             <a:pPr algn="ctr"/>
             <a:r>
-              <a:rPr sz="2000" b="1">
+              <a:rPr sz="950" b="1">
                 <a:solidFill>
                   <a:srgbClr val="2E2A3A"/>
                 </a:solidFill>
@@ -13759,7 +13531,7 @@
         </p:nvSpPr>
         <p:spPr>
           <a:xfrm>
-            <a:off x="3240552" y="3304938"/>
+            <a:off x="3240552" y="3246120"/>
             <a:ext cx="310896" cy="310896"/>
           </a:xfrm>
           <a:prstGeom prst="ellipse">
@@ -13791,7 +13563,6 @@
           <a:lstStyle/>
           <a:p>
             <a:pPr algn="ctr"/>
-            <a:endParaRPr sz="2000" dirty="0"/>
           </a:p>
         </p:txBody>
       </p:sp>
@@ -13803,8 +13574,8 @@
         </p:nvSpPr>
         <p:spPr>
           <a:xfrm>
-            <a:off x="2499870" y="3766876"/>
-            <a:ext cx="1797420" cy="1077218"/>
+            <a:off x="2566000" y="3794760"/>
+            <a:ext cx="1660000" cy="1050000"/>
           </a:xfrm>
           <a:prstGeom prst="rect">
             <a:avLst/>
@@ -13819,143 +13590,34 @@
           <a:p>
             <a:pPr algn="ctr"/>
             <a:r>
-              <a:rPr sz="1600" b="0" dirty="0">
+              <a:rPr sz="850" b="0">
                 <a:solidFill>
                   <a:srgbClr val="4C4954"/>
                 </a:solidFill>
               </a:rPr>
-              <a:t>El </a:t>
-            </a:r>
-            <a:r>
-              <a:rPr sz="1600" b="0" dirty="0" err="1">
+              <a:t>El yo-espejo:</a:t>
+            </a:r>
+          </a:p>
+          <a:p>
+            <a:pPr algn="ctr"/>
+            <a:r>
+              <a:rPr sz="850" b="0">
                 <a:solidFill>
                   <a:srgbClr val="4C4954"/>
                 </a:solidFill>
               </a:rPr>
-              <a:t>yo-espejo</a:t>
-            </a:r>
-            <a:r>
-              <a:rPr sz="1600" b="0" dirty="0">
+              <a:t>nos vemos como</a:t>
+            </a:r>
+          </a:p>
+          <a:p>
+            <a:pPr algn="ctr"/>
+            <a:r>
+              <a:rPr sz="850" b="0">
                 <a:solidFill>
                   <a:srgbClr val="4C4954"/>
                 </a:solidFill>
               </a:rPr>
-              <a:t>:</a:t>
-            </a:r>
-          </a:p>
-          <a:p>
-            <a:pPr algn="ctr"/>
-            <a:r>
-              <a:rPr sz="1600" b="0" dirty="0" err="1">
-                <a:solidFill>
-                  <a:srgbClr val="4C4954"/>
-                </a:solidFill>
-              </a:rPr>
-              <a:t>nos</a:t>
-            </a:r>
-            <a:r>
-              <a:rPr sz="1600" b="0" dirty="0">
-                <a:solidFill>
-                  <a:srgbClr val="4C4954"/>
-                </a:solidFill>
-              </a:rPr>
-              <a:t> </a:t>
-            </a:r>
-            <a:r>
-              <a:rPr sz="1600" b="0" dirty="0" err="1">
-                <a:solidFill>
-                  <a:srgbClr val="4C4954"/>
-                </a:solidFill>
-              </a:rPr>
-              <a:t>vemos</a:t>
-            </a:r>
-            <a:r>
-              <a:rPr sz="1600" b="0" dirty="0">
-                <a:solidFill>
-                  <a:srgbClr val="4C4954"/>
-                </a:solidFill>
-              </a:rPr>
-              <a:t> </a:t>
-            </a:r>
-            <a:r>
-              <a:rPr sz="1600" b="0" dirty="0" err="1">
-                <a:solidFill>
-                  <a:srgbClr val="4C4954"/>
-                </a:solidFill>
-              </a:rPr>
-              <a:t>como</a:t>
-            </a:r>
-            <a:endParaRPr sz="1600" b="0" dirty="0">
-              <a:solidFill>
-                <a:srgbClr val="4C4954"/>
-              </a:solidFill>
-            </a:endParaRPr>
-          </a:p>
-          <a:p>
-            <a:pPr algn="ctr"/>
-            <a:r>
-              <a:rPr sz="1600" b="0" dirty="0" err="1">
-                <a:solidFill>
-                  <a:srgbClr val="4C4954"/>
-                </a:solidFill>
-              </a:rPr>
-              <a:t>nos</a:t>
-            </a:r>
-            <a:r>
-              <a:rPr sz="1600" b="0" dirty="0">
-                <a:solidFill>
-                  <a:srgbClr val="4C4954"/>
-                </a:solidFill>
-              </a:rPr>
-              <a:t> </a:t>
-            </a:r>
-            <a:r>
-              <a:rPr sz="1600" b="0" dirty="0" err="1">
-                <a:solidFill>
-                  <a:srgbClr val="4C4954"/>
-                </a:solidFill>
-              </a:rPr>
-              <a:t>ven</a:t>
-            </a:r>
-            <a:r>
-              <a:rPr sz="1600" b="0" dirty="0">
-                <a:solidFill>
-                  <a:srgbClr val="4C4954"/>
-                </a:solidFill>
-              </a:rPr>
-              <a:t> </a:t>
-            </a:r>
-            <a:r>
-              <a:rPr sz="1600" b="0" dirty="0" err="1">
-                <a:solidFill>
-                  <a:srgbClr val="4C4954"/>
-                </a:solidFill>
-              </a:rPr>
-              <a:t>los</a:t>
-            </a:r>
-            <a:r>
-              <a:rPr sz="1600" b="0" dirty="0">
-                <a:solidFill>
-                  <a:srgbClr val="4C4954"/>
-                </a:solidFill>
-              </a:rPr>
-              <a:t> dem</a:t>
-            </a:r>
-            <a:r>
-              <a:rPr lang="es-ES" sz="1600" b="0" dirty="0">
-                <a:solidFill>
-                  <a:srgbClr val="4C4954"/>
-                </a:solidFill>
-              </a:rPr>
-              <a:t>á</a:t>
-            </a:r>
-            <a:r>
-              <a:rPr sz="1600" b="0" dirty="0">
-                <a:solidFill>
-                  <a:srgbClr val="4C4954"/>
-                </a:solidFill>
-              </a:rPr>
-              <a:t>s.</a:t>
+              <a:t>nos ven los demás.</a:t>
             </a:r>
           </a:p>
         </p:txBody>
@@ -13969,7 +13631,7 @@
         <p:spPr>
           <a:xfrm>
             <a:off x="4366000" y="2148840"/>
-            <a:ext cx="1660000" cy="400110"/>
+            <a:ext cx="1660000" cy="457200"/>
           </a:xfrm>
           <a:prstGeom prst="rect">
             <a:avLst/>
@@ -13984,7 +13646,7 @@
           <a:p>
             <a:pPr algn="ctr"/>
             <a:r>
-              <a:rPr sz="2000" b="1">
+              <a:rPr sz="2600" b="1">
                 <a:solidFill>
                   <a:srgbClr val="9079C8"/>
                 </a:solidFill>
@@ -14003,7 +13665,7 @@
         <p:spPr>
           <a:xfrm>
             <a:off x="4366000" y="2670048"/>
-            <a:ext cx="1660000" cy="400110"/>
+            <a:ext cx="1660000" cy="320040"/>
           </a:xfrm>
           <a:prstGeom prst="rect">
             <a:avLst/>
@@ -14018,7 +13680,7 @@
           <a:p>
             <a:pPr algn="ctr"/>
             <a:r>
-              <a:rPr sz="2000" b="1">
+              <a:rPr sz="950" b="1">
                 <a:solidFill>
                   <a:srgbClr val="2E2A3A"/>
                 </a:solidFill>
@@ -14068,7 +13730,6 @@
           <a:lstStyle/>
           <a:p>
             <a:pPr algn="ctr"/>
-            <a:endParaRPr sz="2000"/>
           </a:p>
         </p:txBody>
       </p:sp>
@@ -14081,7 +13742,7 @@
         <p:spPr>
           <a:xfrm>
             <a:off x="4366000" y="3794760"/>
-            <a:ext cx="1660000" cy="830997"/>
+            <a:ext cx="1660000" cy="1050000"/>
           </a:xfrm>
           <a:prstGeom prst="rect">
             <a:avLst/>
@@ -14096,7 +13757,7 @@
           <a:p>
             <a:pPr algn="ctr"/>
             <a:r>
-              <a:rPr sz="1600" b="0" dirty="0">
+              <a:rPr sz="850" b="0">
                 <a:solidFill>
                   <a:srgbClr val="4C4954"/>
                 </a:solidFill>
@@ -14107,54 +13768,22 @@
           <a:p>
             <a:pPr algn="ctr"/>
             <a:r>
-              <a:rPr sz="1600" b="0" dirty="0" err="1">
+              <a:rPr sz="850" b="0">
                 <a:solidFill>
                   <a:srgbClr val="4C4954"/>
                 </a:solidFill>
               </a:rPr>
-              <a:t>en</a:t>
-            </a:r>
-            <a:r>
-              <a:rPr sz="1600" b="0" dirty="0">
+              <a:t>en la interacción</a:t>
+            </a:r>
+          </a:p>
+          <a:p>
+            <a:pPr algn="ctr"/>
+            <a:r>
+              <a:rPr sz="850" b="0">
                 <a:solidFill>
                   <a:srgbClr val="4C4954"/>
                 </a:solidFill>
               </a:rPr>
-              <a:t> la </a:t>
-            </a:r>
-            <a:r>
-              <a:rPr sz="1600" b="0" dirty="0" err="1">
-                <a:solidFill>
-                  <a:srgbClr val="4C4954"/>
-                </a:solidFill>
-              </a:rPr>
-              <a:t>interacci</a:t>
-            </a:r>
-            <a:r>
-              <a:rPr lang="es-ES" sz="1600" b="0" dirty="0" err="1">
-                <a:solidFill>
-                  <a:srgbClr val="4C4954"/>
-                </a:solidFill>
-              </a:rPr>
-              <a:t>ó</a:t>
-            </a:r>
-            <a:r>
-              <a:rPr sz="1600" b="0" dirty="0">
-                <a:solidFill>
-                  <a:srgbClr val="4C4954"/>
-                </a:solidFill>
-              </a:rPr>
-              <a:t>n</a:t>
-            </a:r>
-          </a:p>
-          <a:p>
-            <a:pPr algn="ctr"/>
-            <a:r>
-              <a:rPr sz="1600" b="0" dirty="0">
-                <a:solidFill>
-                  <a:srgbClr val="4C4954"/>
-                </a:solidFill>
-              </a:rPr>
               <a:t>social.</a:t>
             </a:r>
           </a:p>
@@ -14169,7 +13798,7 @@
         <p:spPr>
           <a:xfrm>
             <a:off x="6166000" y="2148840"/>
-            <a:ext cx="1660000" cy="400110"/>
+            <a:ext cx="1660000" cy="457200"/>
           </a:xfrm>
           <a:prstGeom prst="rect">
             <a:avLst/>
@@ -14184,7 +13813,7 @@
           <a:p>
             <a:pPr algn="ctr"/>
             <a:r>
-              <a:rPr sz="2000" b="1">
+              <a:rPr sz="2600" b="1">
                 <a:solidFill>
                   <a:srgbClr val="9079C8"/>
                 </a:solidFill>
@@ -14203,7 +13832,7 @@
         <p:spPr>
           <a:xfrm>
             <a:off x="6166000" y="2670048"/>
-            <a:ext cx="1660000" cy="400110"/>
+            <a:ext cx="1660000" cy="320040"/>
           </a:xfrm>
           <a:prstGeom prst="rect">
             <a:avLst/>
@@ -14218,7 +13847,7 @@
           <a:p>
             <a:pPr algn="ctr"/>
             <a:r>
-              <a:rPr sz="2000" b="1">
+              <a:rPr sz="950" b="1">
                 <a:solidFill>
                   <a:srgbClr val="2E2A3A"/>
                 </a:solidFill>
@@ -14268,7 +13897,6 @@
           <a:lstStyle/>
           <a:p>
             <a:pPr algn="ctr"/>
-            <a:endParaRPr sz="2000"/>
           </a:p>
         </p:txBody>
       </p:sp>
@@ -14281,7 +13909,7 @@
         <p:spPr>
           <a:xfrm>
             <a:off x="6166000" y="3794760"/>
-            <a:ext cx="1660000" cy="1077218"/>
+            <a:ext cx="1660000" cy="1050000"/>
           </a:xfrm>
           <a:prstGeom prst="rect">
             <a:avLst/>
@@ -14296,7 +13924,7 @@
           <a:p>
             <a:pPr algn="ctr"/>
             <a:r>
-              <a:rPr sz="1600" b="0" dirty="0">
+              <a:rPr sz="850" b="0">
                 <a:solidFill>
                   <a:srgbClr val="4C4954"/>
                 </a:solidFill>
@@ -14307,55 +13935,23 @@
           <a:p>
             <a:pPr algn="ctr"/>
             <a:r>
-              <a:rPr sz="1600" b="0" dirty="0" err="1">
+              <a:rPr sz="850" b="0">
                 <a:solidFill>
                   <a:srgbClr val="4C4954"/>
                 </a:solidFill>
               </a:rPr>
-              <a:t>est</a:t>
-            </a:r>
-            <a:r>
-              <a:rPr lang="es-ES" sz="1600" b="0" dirty="0">
+              <a:t>estándar de la</a:t>
+            </a:r>
+          </a:p>
+          <a:p>
+            <a:pPr algn="ctr"/>
+            <a:r>
+              <a:rPr sz="850" b="0">
                 <a:solidFill>
                   <a:srgbClr val="4C4954"/>
                 </a:solidFill>
               </a:rPr>
-              <a:t>á</a:t>
-            </a:r>
-            <a:r>
-              <a:rPr sz="1600" b="0" dirty="0" err="1">
-                <a:solidFill>
-                  <a:srgbClr val="4C4954"/>
-                </a:solidFill>
-              </a:rPr>
-              <a:t>ndar</a:t>
-            </a:r>
-            <a:r>
-              <a:rPr sz="1600" b="0" dirty="0">
-                <a:solidFill>
-                  <a:srgbClr val="4C4954"/>
-                </a:solidFill>
-              </a:rPr>
-              <a:t> de la</a:t>
-            </a:r>
-          </a:p>
-          <a:p>
-            <a:pPr algn="ctr"/>
-            <a:r>
-              <a:rPr sz="1600" b="0" dirty="0" err="1">
-                <a:solidFill>
-                  <a:srgbClr val="4C4954"/>
-                </a:solidFill>
-              </a:rPr>
-              <a:t>autoestima</a:t>
-            </a:r>
-            <a:r>
-              <a:rPr sz="1600" b="0" dirty="0">
-                <a:solidFill>
-                  <a:srgbClr val="4C4954"/>
-                </a:solidFill>
-              </a:rPr>
-              <a:t> global.</a:t>
+              <a:t>autoestima global.</a:t>
             </a:r>
           </a:p>
         </p:txBody>
@@ -14369,7 +13965,7 @@
         <p:spPr>
           <a:xfrm>
             <a:off x="7966000" y="2148840"/>
-            <a:ext cx="1660000" cy="400110"/>
+            <a:ext cx="1660000" cy="457200"/>
           </a:xfrm>
           <a:prstGeom prst="rect">
             <a:avLst/>
@@ -14384,7 +13980,7 @@
           <a:p>
             <a:pPr algn="ctr"/>
             <a:r>
-              <a:rPr sz="2000" b="1">
+              <a:rPr sz="2600" b="1">
                 <a:solidFill>
                   <a:srgbClr val="9079C8"/>
                 </a:solidFill>
@@ -14403,7 +13999,7 @@
         <p:spPr>
           <a:xfrm>
             <a:off x="7966000" y="2670048"/>
-            <a:ext cx="1660000" cy="400110"/>
+            <a:ext cx="1660000" cy="320040"/>
           </a:xfrm>
           <a:prstGeom prst="rect">
             <a:avLst/>
@@ -14418,7 +14014,7 @@
           <a:p>
             <a:pPr algn="ctr"/>
             <a:r>
-              <a:rPr sz="2000" b="1">
+              <a:rPr sz="950" b="1">
                 <a:solidFill>
                   <a:srgbClr val="2E2A3A"/>
                 </a:solidFill>
@@ -14468,7 +14064,6 @@
           <a:lstStyle/>
           <a:p>
             <a:pPr algn="ctr"/>
-            <a:endParaRPr sz="2000"/>
           </a:p>
         </p:txBody>
       </p:sp>
@@ -14481,7 +14076,7 @@
         <p:spPr>
           <a:xfrm>
             <a:off x="7966000" y="3794760"/>
-            <a:ext cx="1798710" cy="830997"/>
+            <a:ext cx="1660000" cy="1050000"/>
           </a:xfrm>
           <a:prstGeom prst="rect">
             <a:avLst/>
@@ -14496,23 +14091,18 @@
           <a:p>
             <a:pPr algn="ctr"/>
             <a:r>
-              <a:rPr sz="1600" b="0" dirty="0" err="1">
+              <a:rPr sz="850" b="0">
                 <a:solidFill>
                   <a:srgbClr val="4C4954"/>
                 </a:solidFill>
               </a:rPr>
               <a:t>Autoconcepto</a:t>
             </a:r>
-            <a:endParaRPr sz="1600" b="0" dirty="0">
-              <a:solidFill>
-                <a:srgbClr val="4C4954"/>
-              </a:solidFill>
-            </a:endParaRPr>
           </a:p>
           <a:p>
             <a:pPr algn="ctr"/>
             <a:r>
-              <a:rPr sz="1600" b="0" dirty="0">
+              <a:rPr sz="850" b="0">
                 <a:solidFill>
                   <a:srgbClr val="4C4954"/>
                 </a:solidFill>
@@ -14523,44 +14113,12 @@
           <a:p>
             <a:pPr algn="ctr"/>
             <a:r>
-              <a:rPr sz="1600" b="0" dirty="0">
+              <a:rPr sz="850" b="0">
                 <a:solidFill>
                   <a:srgbClr val="4C4954"/>
                 </a:solidFill>
               </a:rPr>
-              <a:t>y </a:t>
-            </a:r>
-            <a:r>
-              <a:rPr sz="1600" b="0" dirty="0" err="1">
-                <a:solidFill>
-                  <a:srgbClr val="4C4954"/>
-                </a:solidFill>
-              </a:rPr>
-              <a:t>jer</a:t>
-            </a:r>
-            <a:r>
-              <a:rPr lang="es-ES" sz="1600" b="0" dirty="0">
-                <a:solidFill>
-                  <a:srgbClr val="4C4954"/>
-                </a:solidFill>
-              </a:rPr>
-              <a:t>á</a:t>
-            </a:r>
-            <a:r>
-              <a:rPr sz="1600" b="0" dirty="0" err="1">
-                <a:solidFill>
-                  <a:srgbClr val="4C4954"/>
-                </a:solidFill>
-              </a:rPr>
-              <a:t>rquico</a:t>
-            </a:r>
-            <a:r>
-              <a:rPr sz="1600" b="0" dirty="0">
-                <a:solidFill>
-                  <a:srgbClr val="4C4954"/>
-                </a:solidFill>
-              </a:rPr>
-              <a:t>.</a:t>
+              <a:t>y jerárquico.</a:t>
             </a:r>
           </a:p>
         </p:txBody>
@@ -14574,7 +14132,7 @@
         <p:spPr>
           <a:xfrm>
             <a:off x="9766000" y="2148840"/>
-            <a:ext cx="1660000" cy="400110"/>
+            <a:ext cx="1660000" cy="457200"/>
           </a:xfrm>
           <a:prstGeom prst="rect">
             <a:avLst/>
@@ -14589,7 +14147,7 @@
           <a:p>
             <a:pPr algn="ctr"/>
             <a:r>
-              <a:rPr sz="2000" b="1">
+              <a:rPr sz="2600" b="1">
                 <a:solidFill>
                   <a:srgbClr val="9079C8"/>
                 </a:solidFill>
@@ -14608,7 +14166,7 @@
         <p:spPr>
           <a:xfrm>
             <a:off x="9766000" y="2670048"/>
-            <a:ext cx="1660000" cy="400110"/>
+            <a:ext cx="1660000" cy="320040"/>
           </a:xfrm>
           <a:prstGeom prst="rect">
             <a:avLst/>
@@ -14623,7 +14181,7 @@
           <a:p>
             <a:pPr algn="ctr"/>
             <a:r>
-              <a:rPr sz="2000" b="1">
+              <a:rPr sz="950" b="1">
                 <a:solidFill>
                   <a:srgbClr val="2E2A3A"/>
                 </a:solidFill>
@@ -14673,7 +14231,6 @@
           <a:lstStyle/>
           <a:p>
             <a:pPr algn="ctr"/>
-            <a:endParaRPr sz="2000"/>
           </a:p>
         </p:txBody>
       </p:sp>
@@ -14686,7 +14243,7 @@
         <p:spPr>
           <a:xfrm>
             <a:off x="9766000" y="3794760"/>
-            <a:ext cx="1660000" cy="1077218"/>
+            <a:ext cx="1660000" cy="1050000"/>
           </a:xfrm>
           <a:prstGeom prst="rect">
             <a:avLst/>
@@ -14701,103 +14258,34 @@
           <a:p>
             <a:pPr algn="ctr"/>
             <a:r>
-              <a:rPr sz="1600" b="0" dirty="0">
+              <a:rPr sz="850" b="0">
                 <a:solidFill>
                   <a:srgbClr val="4C4954"/>
                 </a:solidFill>
               </a:rPr>
-              <a:t>La </a:t>
-            </a:r>
-            <a:r>
-              <a:rPr sz="1600" b="0" dirty="0" err="1">
+              <a:t>Efectos causales</a:t>
+            </a:r>
+          </a:p>
+          <a:p>
+            <a:pPr algn="ctr"/>
+            <a:r>
+              <a:rPr sz="850" b="0">
                 <a:solidFill>
                   <a:srgbClr val="4C4954"/>
                 </a:solidFill>
               </a:rPr>
-              <a:t>alta</a:t>
-            </a:r>
-            <a:r>
-              <a:rPr sz="1600" b="0" dirty="0">
+              <a:t>más modestos de lo</a:t>
+            </a:r>
+          </a:p>
+          <a:p>
+            <a:pPr algn="ctr"/>
+            <a:r>
+              <a:rPr sz="850" b="0">
                 <a:solidFill>
                   <a:srgbClr val="4C4954"/>
                 </a:solidFill>
               </a:rPr>
-              <a:t> </a:t>
-            </a:r>
-            <a:r>
-              <a:rPr sz="1600" b="0" dirty="0" err="1">
-                <a:solidFill>
-                  <a:srgbClr val="4C4954"/>
-                </a:solidFill>
-              </a:rPr>
-              <a:t>autoestima</a:t>
-            </a:r>
-            <a:endParaRPr sz="1600" b="0" dirty="0">
-              <a:solidFill>
-                <a:srgbClr val="4C4954"/>
-              </a:solidFill>
-            </a:endParaRPr>
-          </a:p>
-          <a:p>
-            <a:pPr algn="ctr"/>
-            <a:r>
-              <a:rPr sz="1600" b="0" dirty="0">
-                <a:solidFill>
-                  <a:srgbClr val="4C4954"/>
-                </a:solidFill>
-              </a:rPr>
-              <a:t>no causa </a:t>
-            </a:r>
-            <a:r>
-              <a:rPr sz="1600" b="0" dirty="0" err="1">
-                <a:solidFill>
-                  <a:srgbClr val="4C4954"/>
-                </a:solidFill>
-              </a:rPr>
-              <a:t>todo</a:t>
-            </a:r>
-            <a:r>
-              <a:rPr sz="1600" b="0" dirty="0">
-                <a:solidFill>
-                  <a:srgbClr val="4C4954"/>
-                </a:solidFill>
-              </a:rPr>
-              <a:t>:</a:t>
-            </a:r>
-          </a:p>
-          <a:p>
-            <a:pPr algn="ctr"/>
-            <a:r>
-              <a:rPr sz="1600" b="0" dirty="0" err="1">
-                <a:solidFill>
-                  <a:srgbClr val="4C4954"/>
-                </a:solidFill>
-              </a:rPr>
-              <a:t>pide</a:t>
-            </a:r>
-            <a:r>
-              <a:rPr sz="1600" b="0" dirty="0">
-                <a:solidFill>
-                  <a:srgbClr val="4C4954"/>
-                </a:solidFill>
-              </a:rPr>
-              <a:t> m</a:t>
-            </a:r>
-            <a:r>
-              <a:rPr lang="es-ES" sz="1600" dirty="0">
-                <a:solidFill>
-                  <a:srgbClr val="4C4954"/>
-                </a:solidFill>
-              </a:rPr>
-              <a:t>á</a:t>
-            </a:r>
-            <a:r>
-              <a:rPr sz="1600" b="0" dirty="0">
-                <a:solidFill>
-                  <a:srgbClr val="4C4954"/>
-                </a:solidFill>
-              </a:rPr>
-              <a:t>s rigor.</a:t>
+              <a:t>esperado: urge rigor.</a:t>
             </a:r>
           </a:p>
         </p:txBody>
@@ -21767,8 +21255,8 @@
         </p:nvSpPr>
         <p:spPr>
           <a:xfrm>
-            <a:off x="612843" y="521208"/>
-            <a:ext cx="438134" cy="182880"/>
+            <a:off x="749808" y="566928"/>
+            <a:ext cx="310896" cy="91440"/>
           </a:xfrm>
           <a:prstGeom prst="roundRect">
             <a:avLst>
@@ -21802,7 +21290,7 @@
           <a:lstStyle/>
           <a:p>
             <a:pPr algn="ctr"/>
-            <a:endParaRPr sz="3200"/>
+            <a:endParaRPr/>
           </a:p>
         </p:txBody>
       </p:sp>
@@ -21814,7 +21302,7 @@
         </p:nvSpPr>
         <p:spPr>
           <a:xfrm>
-            <a:off x="1168097" y="457200"/>
+            <a:off x="1207007" y="457200"/>
             <a:ext cx="10515600" cy="292608"/>
           </a:xfrm>
           <a:prstGeom prst="rect">
@@ -21828,7 +21316,7 @@
           <a:p>
             <a:pPr algn="l"/>
             <a:r>
-              <a:rPr b="1" spc="140" dirty="0">
+              <a:rPr sz="1150" b="1" spc="140">
                 <a:solidFill>
                   <a:srgbClr val="9079C8"/>
                 </a:solidFill>
@@ -21861,29 +21349,14 @@
           <a:p>
             <a:pPr algn="l"/>
             <a:r>
-              <a:rPr sz="3000" b="0" dirty="0">
+              <a:rPr sz="3000" b="0">
                 <a:solidFill>
                   <a:srgbClr val="2E2A3A"/>
                 </a:solidFill>
                 <a:latin typeface="Segoe UI Semibold"/>
               </a:rPr>
-              <a:t>13 meta-</a:t>
-            </a:r>
-            <a:r>
-              <a:rPr sz="3000" b="0" dirty="0" err="1">
-                <a:solidFill>
-                  <a:srgbClr val="2E2A3A"/>
-                </a:solidFill>
-                <a:latin typeface="Segoe UI Semibold"/>
-              </a:rPr>
-              <a:t>análisis</a:t>
-            </a:r>
-            <a:endParaRPr sz="3000" b="0" dirty="0">
-              <a:solidFill>
-                <a:srgbClr val="2E2A3A"/>
-              </a:solidFill>
-              <a:latin typeface="Segoe UI Semibold"/>
-            </a:endParaRPr>
+              <a:t>13 meta-análisis, mucha diversidad</a:t>
+            </a:r>
           </a:p>
         </p:txBody>
       </p:sp>

</xml_diff>